<commit_message>
Place wide QR and caption together beside the title frame
Co-authored-by: Copilot <223556219+Copilot@users.noreply.github.com>
Copilot-Session: 3eea8efa-fa4d-474d-a38d-b21d9069f61c
</commit_message>
<xml_diff>
--- a/versions/02-starry/Wide/Editable.pptx
+++ b/versions/02-starry/Wide/Editable.pptx
@@ -4241,7 +4241,7 @@
         </p:blipFill>
         <p:spPr>
           <a:xfrm>
-            <a:off x="4752496" y="3600087"/>
+            <a:off x="6723972" y="3181029"/>
             <a:ext cx="457153" cy="457153"/>
           </a:xfrm>
           <a:prstGeom prst="rect">
@@ -4257,8 +4257,8 @@
         </p:nvSpPr>
         <p:spPr>
           <a:xfrm>
-            <a:off x="5266794" y="3695327"/>
-            <a:ext cx="1619086" cy="266673"/>
+            <a:off x="6523967" y="3685803"/>
+            <a:ext cx="857163" cy="142860"/>
           </a:xfrm>
           <a:prstGeom prst="rect">
             <a:avLst/>
@@ -4273,7 +4273,7 @@
           <a:p>
             <a:pPr algn="ctr" rtl="1"/>
             <a:r>
-              <a:rPr sz="824" b="0" lang="he-IL">
+              <a:rPr sz="674" b="0" lang="he-IL">
                 <a:solidFill>
                   <a:srgbClr val="D9C6AB"/>
                 </a:solidFill>

</xml_diff>

<commit_message>
Align wide information panel and lower WhatsApp QR block
Co-authored-by: Copilot <223556219+Copilot@users.noreply.github.com>
Copilot-Session: 3eea8efa-fa4d-474d-a38d-b21d9069f61c
</commit_message>
<xml_diff>
--- a/versions/02-starry/Wide/Editable.pptx
+++ b/versions/02-starry/Wide/Editable.pptx
@@ -3837,7 +3837,7 @@
         </p:nvSpPr>
         <p:spPr>
           <a:xfrm>
-            <a:off x="2171481" y="580966"/>
+            <a:off x="2171481" y="438105"/>
             <a:ext cx="1609562" cy="266673"/>
           </a:xfrm>
           <a:prstGeom prst="rect">
@@ -3873,7 +3873,7 @@
         </p:nvSpPr>
         <p:spPr>
           <a:xfrm>
-            <a:off x="2171481" y="895259"/>
+            <a:off x="2171481" y="752399"/>
             <a:ext cx="1609562" cy="457153"/>
           </a:xfrm>
           <a:prstGeom prst="rect">
@@ -3909,7 +3909,7 @@
         </p:nvSpPr>
         <p:spPr>
           <a:xfrm>
-            <a:off x="428581" y="580966"/>
+            <a:off x="428581" y="438105"/>
             <a:ext cx="1609562" cy="266673"/>
           </a:xfrm>
           <a:prstGeom prst="rect">
@@ -3945,7 +3945,7 @@
         </p:nvSpPr>
         <p:spPr>
           <a:xfrm>
-            <a:off x="428581" y="904783"/>
+            <a:off x="428581" y="761923"/>
             <a:ext cx="1609562" cy="457153"/>
           </a:xfrm>
           <a:prstGeom prst="rect">
@@ -4241,7 +4241,7 @@
         </p:blipFill>
         <p:spPr>
           <a:xfrm>
-            <a:off x="6723972" y="3181029"/>
+            <a:off x="6723972" y="3371510"/>
             <a:ext cx="457153" cy="457153"/>
           </a:xfrm>
           <a:prstGeom prst="rect">
@@ -4257,7 +4257,7 @@
         </p:nvSpPr>
         <p:spPr>
           <a:xfrm>
-            <a:off x="6523967" y="3685803"/>
+            <a:off x="6523967" y="3876284"/>
             <a:ext cx="857163" cy="142860"/>
           </a:xfrm>
           <a:prstGeom prst="rect">

</xml_diff>